<commit_message>
Video-Folien: falsches Logo korrigiert (goldenes Gehirn auf Creme)
Der Cover-Logo-Pfad zeigte auf tools/pdf/assets/brain-freigestellt.png –
ein türkis-grünes Gehirn auf SCHWARZEM Grund (nicht freigestellt), das auf
dem Creme-Grund als schwarzer Kasten erschien. Jetzt public/logo-brain-gold.png
(goldenes Gehirn, transparent) – identisch zum Drehbuch-Cover. Höhe skaliert
automatisch (kein Verzerren). Betrifft alle sieben Decks.

Co-Authored-By: Claude Opus 4.8 <noreply@anthropic.com>
Claude-Session: https://claude.ai/code/session_01GNBFqC5xq6WYVLqLCC99De
</commit_message>
<xml_diff>
--- a/docs/video/WMDG-Video-Folien-Reel.pptx
+++ b/docs/video/WMDG-Video-Folien-Reel.pptx
@@ -3155,7 +3155,7 @@
       </p:sp>
       <p:pic>
         <p:nvPicPr>
-          <p:cNvPr id="3" name="Picture 2" descr="brain-freigestellt.png"/>
+          <p:cNvPr id="3" name="Picture 2" descr="logo-brain-gold.png"/>
           <p:cNvPicPr>
             <a:picLocks noChangeAspect="1"/>
           </p:cNvPicPr>
@@ -3170,7 +3170,7 @@
         <p:spPr>
           <a:xfrm>
             <a:off x="2651760" y="2194560"/>
-            <a:ext cx="1554480" cy="1554480"/>
+            <a:ext cx="1554480" cy="1484528"/>
           </a:xfrm>
           <a:prstGeom prst="rect">
             <a:avLst/>

</xml_diff>